<commit_message>
Finalize visual review and add distribution links
</commit_message>
<xml_diff>
--- a/slides/Claude-Code-上級業務設計編.pptx
+++ b/slides/Claude-Code-上級業務設計編.pptx
@@ -3483,6 +3483,12 @@
               <a:t>GitHub教材から原本・実行例・期待値・出典・検証手順を案内。</a:t>
             </a:r>
           </a:p>
+          <a:p/>
+          <a:p>
+            <a:r>
+              <a:t>配布教材：https://github.com/takpfive/aimokuyokai-claude-code-course-20261031</a:t>
+            </a:r>
+          </a:p>
         </p:txBody>
       </p:sp>
       <p:sp>
@@ -16519,6 +16525,9 @@
           <a:lstStyle/>
           <a:p>
             <a:r>
+              <a:rPr>
+                <a:hlinkClick r:id="rId3"/>
+              </a:rPr>
               <a:t>配布教材：README → 演習 → 検証</a:t>
             </a:r>
           </a:p>

</xml_diff>